<commit_message>
Update audit overview deck and add ERP team roles surfaces
Made-with: Cursor
</commit_message>
<xml_diff>
--- a/outputs/presentations/Audit Committee ERP Overview.pptx
+++ b/outputs/presentations/Audit Committee ERP Overview.pptx
@@ -3796,7 +3796,7 @@
                 </a:solidFill>
                 <a:latin typeface="Calibri"/>
               </a:rPr>
-              <a:t>NetSuite selected over SAP on February 26, 2026. Program mobilizes April 2026, go-live January 1, 2027.</a:t>
+              <a:t>NetSuite selected February 26, 2026. Implementation mobilization: April 2026. Go-live: January 1, 2027.</a:t>
             </a:r>
           </a:p>
         </p:txBody>
@@ -3954,7 +3954,7 @@
                 </a:solidFill>
                 <a:latin typeface="Calibri"/>
               </a:rPr>
-              <a:t>Why We're Doing This</a:t>
+              <a:t>Business Rationale</a:t>
             </a:r>
           </a:p>
         </p:txBody>
@@ -3989,7 +3989,7 @@
                 </a:solidFill>
                 <a:latin typeface="Calibri"/>
               </a:rPr>
-              <a:t>• Current finance systems (Sage 100) are fragmented and manual.</a:t>
+              <a:t>• Current systems (Sage 100, legacy tools) are fragmented and highly manual across P2P, close, and reporting.</a:t>
             </a:r>
           </a:p>
           <a:p>
@@ -4005,7 +4005,7 @@
                 </a:solidFill>
                 <a:latin typeface="Calibri"/>
               </a:rPr>
-              <a:t>• Controls are inconsistent across P2P, reporting, and close processes.</a:t>
+              <a:t>• Controls environment is inconsistent and not adequate for SEC filing scrutiny or public-company audit standards.</a:t>
             </a:r>
           </a:p>
           <a:p>
@@ -4021,7 +4021,7 @@
                 </a:solidFill>
                 <a:latin typeface="Calibri"/>
               </a:rPr>
-              <a:t>• Not scalable for SEC filing scrutiny or US public market launch in 2027.</a:t>
+              <a:t>• US public market launch targeted December 2027. ERP go-live by January 2027 is a hard dependency.</a:t>
             </a:r>
           </a:p>
           <a:p>
@@ -4037,7 +4037,7 @@
                 </a:solidFill>
                 <a:latin typeface="Calibri"/>
               </a:rPr>
-              <a:t>• ERP is a SOX-remediation and operational modernization program, not a technology swap.</a:t>
+              <a:t>• SOX-readiness is the primary driver, not a technology swap.</a:t>
             </a:r>
           </a:p>
         </p:txBody>
@@ -4195,7 +4195,7 @@
                 </a:solidFill>
                 <a:latin typeface="Calibri"/>
               </a:rPr>
-              <a:t>Why NetSuite</a:t>
+              <a:t>Selection Rationale</a:t>
             </a:r>
           </a:p>
         </p:txBody>
@@ -4230,7 +4230,7 @@
                 </a:solidFill>
                 <a:latin typeface="Calibri"/>
               </a:rPr>
-              <a:t>• Implementation speed: 9 months vs 18+ for SAP.</a:t>
+              <a:t>• Multi-currency, multi-GAAP, bilingual (FR/EN) architecture built to scale with Abivax's France and US footprint.</a:t>
             </a:r>
           </a:p>
           <a:p>
@@ -4246,7 +4246,7 @@
                 </a:solidFill>
                 <a:latin typeface="Calibri"/>
               </a:rPr>
-              <a:t>• SaaS-native architecture, no on-premise infrastructure.</a:t>
+              <a:t>• Stronger controls from day one: segregation of duties, audit trail, and SOX-ready approval workflows.</a:t>
             </a:r>
           </a:p>
           <a:p>
@@ -4262,7 +4262,7 @@
                 </a:solidFill>
                 <a:latin typeface="Calibri"/>
               </a:rPr>
-              <a:t>• Proven biotech install base with multi-GAAP and multi-entity capability.</a:t>
+              <a:t>• Vendor-led delivery by NetSuite's own implementation team, ensuring product expertise and faster issue resolution.</a:t>
             </a:r>
           </a:p>
           <a:p>
@@ -4278,7 +4278,7 @@
                 </a:solidFill>
                 <a:latin typeface="Calibri"/>
               </a:rPr>
-              <a:t>• NetSuite-led delivery (Ali Brahmi, lead consultant), no third-party implementer needed.</a:t>
+              <a:t>• KPMG led requirements definition and solution selection, confirming NetSuite as the best fit for Abivax's size and context.</a:t>
             </a:r>
           </a:p>
         </p:txBody>
@@ -4487,7 +4487,7 @@
                 </a:solidFill>
                 <a:latin typeface="Calibri"/>
               </a:rPr>
-              <a:t>• Executive Sponsor: Hema Keshava (CFO)</a:t>
+              <a:t>• Executive Sponsor: Didier Blondel (CFO)</a:t>
             </a:r>
           </a:p>
           <a:p>
@@ -4503,7 +4503,7 @@
                 </a:solidFill>
                 <a:latin typeface="Calibri"/>
               </a:rPr>
-              <a:t>• Finance Process Lead: Trinidad Mesa (France)</a:t>
+              <a:t>• Finance Lead: Hema Keshava (Head of Finance)</a:t>
             </a:r>
           </a:p>
           <a:p>
@@ -4519,7 +4519,7 @@
                 </a:solidFill>
                 <a:latin typeface="Calibri"/>
               </a:rPr>
-              <a:t>• Implementation: NetSuite delivery team (Oracle)</a:t>
+              <a:t>• Finance Process Lead: Trinidad Mesa (France)</a:t>
             </a:r>
           </a:p>
           <a:p>
@@ -4535,7 +4535,23 @@
                 </a:solidFill>
                 <a:latin typeface="Calibri"/>
               </a:rPr>
-              <a:t>• Advisory support: KPMG (scope TBC)</a:t>
+              <a:t>• Implementation: NetSuite delivery team (Oracle)</a:t>
+            </a:r>
+          </a:p>
+          <a:p>
+            <a:pPr algn="l">
+              <a:spcBef>
+                <a:spcPts val="600"/>
+              </a:spcBef>
+            </a:pPr>
+            <a:r>
+              <a:rPr sz="1300">
+                <a:solidFill>
+                  <a:srgbClr val="475569"/>
+                </a:solidFill>
+                <a:latin typeface="Calibri"/>
+              </a:rPr>
+              <a:t>• Advisory: KPMG (selection phase support)</a:t>
             </a:r>
           </a:p>
         </p:txBody>

</xml_diff>